<commit_message>
Stamp QER-RC1 as 5.2.0-rc.6-wizard.5.17
Set the release name to EU_SAE_520_w5q and refresh the guides and generated
pages. Repair the links that failed the navigation check and record the two
changed documents in the bridge receipt. Keep the dated w5p validation receipt
and guidance change record as historical documents.

Co-Authored-By: Claude Opus 5.5 <noreply@anthropic.com>
</commit_message>
<xml_diff>
--- a/docs/instructions/English/EU_SAE_Workbench_Guide_1_Install_and_Start.pptx
+++ b/docs/instructions/English/EU_SAE_Workbench_Guide_1_Install_and_Start.pptx
@@ -4932,7 +4932,7 @@
                   <a:srgbClr val="33415C"/>
                 </a:solidFill>
               </a:rPr>
-              <a:t>Under Assets, for example EU_SAE_520_w5p.zip. Not the 'Source code' archives.</a:t>
+              <a:t>Under Assets, for example EU_SAE_520_w5q.zip. Not the 'Source code' archives.</a:t>
             </a:r>
             <a:endParaRPr lang="en-US" sz="1300" dirty="0"/>
           </a:p>
@@ -5232,7 +5232,7 @@
                 <a:ea typeface="Courier New" pitchFamily="34" charset="-122"/>
                 <a:cs typeface="Courier New" pitchFamily="34" charset="-120"/>
               </a:rPr>
-              <a:t>EU_SAE_520_w5p/</a:t>
+              <a:t>EU_SAE_520_w5q/</a:t>
             </a:r>
             <a:endParaRPr lang="en-US" sz="1050" dirty="0"/>
           </a:p>

</xml_diff>

<commit_message>
Prepare QER-RC2 as 5.2.0-rc.6-wizard.5.18
Fix the step 4 findings on QER-RC1. Stop saving survey rows through the
environment of saved MFH formulas. Reject Comparison unless UFH and MFH run
together, and stop clearly when variance smoothing explodes. Repair the Polish
and Greek guide decks, which PowerPoint could not open, and regenerate their
PDFs. Set the release name to EU_SAE_520_w5r.

Co-Authored-By: Claude Opus 5.5 <noreply@anthropic.com>
</commit_message>
<xml_diff>
--- a/docs/instructions/English/EU_SAE_Workbench_Guide_1_Install_and_Start.pptx
+++ b/docs/instructions/English/EU_SAE_Workbench_Guide_1_Install_and_Start.pptx
@@ -4932,7 +4932,7 @@
                   <a:srgbClr val="33415C"/>
                 </a:solidFill>
               </a:rPr>
-              <a:t>Under Assets, for example EU_SAE_520_w5q.zip. Not the 'Source code' archives.</a:t>
+              <a:t>Under Assets, for example EU_SAE_520_w5r.zip. Not the 'Source code' archives.</a:t>
             </a:r>
             <a:endParaRPr lang="en-US" sz="1300" dirty="0"/>
           </a:p>
@@ -5232,7 +5232,7 @@
                 <a:ea typeface="Courier New" pitchFamily="34" charset="-122"/>
                 <a:cs typeface="Courier New" pitchFamily="34" charset="-120"/>
               </a:rPr>
-              <a:t>EU_SAE_520_w5q/</a:t>
+              <a:t>EU_SAE_520_w5r/</a:t>
             </a:r>
             <a:endParaRPr lang="en-US" sz="1050" dirty="0"/>
           </a:p>

</xml_diff>

<commit_message>
Prepare QER-RC3 as 5.2.0-rc.6-wizard.5.19
Report how many MFH direct variances were replaced by smoothing, so a run with
many zero or missing variances no longer looks like an ordinary one. Estimates
are unchanged. Set the release name to EU_SAE_520_w5s.

Co-Authored-By: Claude Opus 5.5 <noreply@anthropic.com>
</commit_message>
<xml_diff>
--- a/docs/instructions/English/EU_SAE_Workbench_Guide_1_Install_and_Start.pptx
+++ b/docs/instructions/English/EU_SAE_Workbench_Guide_1_Install_and_Start.pptx
@@ -4932,7 +4932,7 @@
                   <a:srgbClr val="33415C"/>
                 </a:solidFill>
               </a:rPr>
-              <a:t>Under Assets, for example EU_SAE_520_w5r.zip. Not the 'Source code' archives.</a:t>
+              <a:t>Under Assets, for example EU_SAE_520_w5s.zip. Not the 'Source code' archives.</a:t>
             </a:r>
             <a:endParaRPr lang="en-US" sz="1300" dirty="0"/>
           </a:p>
@@ -5232,7 +5232,7 @@
                 <a:ea typeface="Courier New" pitchFamily="34" charset="-122"/>
                 <a:cs typeface="Courier New" pitchFamily="34" charset="-120"/>
               </a:rPr>
-              <a:t>EU_SAE_520_w5r/</a:t>
+              <a:t>EU_SAE_520_w5s/</a:t>
             </a:r>
             <a:endParaRPr lang="en-US" sz="1050" dirty="0"/>
           </a:p>

</xml_diff>